<commit_message>
feat: implement logic to manage ordered list restarts and calculate next item number in PPTX conversion
</commit_message>
<xml_diff>
--- a/demo/office_docs/pptx_01.pptx
+++ b/demo/office_docs/pptx_01.pptx
@@ -5,7 +5,7 @@
     <p:sldMasterId id="2147483648" r:id="rId1"/>
   </p:sldMasterIdLst>
   <p:notesMasterIdLst>
-    <p:notesMasterId r:id="rId7"/>
+    <p:notesMasterId r:id="rId8"/>
   </p:notesMasterIdLst>
   <p:sldIdLst>
     <p:sldId id="256" r:id="rId2"/>
@@ -13,6 +13,7 @@
     <p:sldId id="258" r:id="rId4"/>
     <p:sldId id="259" r:id="rId5"/>
     <p:sldId id="260" r:id="rId6"/>
+    <p:sldId id="261" r:id="rId7"/>
   </p:sldIdLst>
   <p:sldSz cx="12192000" cy="6858000"/>
   <p:notesSz cx="6858000" cy="9144000"/>
@@ -1201,7 +1202,7 @@
           <a:p>
             <a:fld id="{0F89C1C7-3DCD-1040-A9CF-14679D8B5DDD}" type="datetimeFigureOut">
               <a:rPr lang="en-US" smtClean="0"/>
-              <a:t>4/16/26</a:t>
+              <a:t>5/14/26</a:t>
             </a:fld>
             <a:endParaRPr lang="en-US"/>
           </a:p>
@@ -1739,7 +1740,7 @@
           <a:p>
             <a:fld id="{376CE277-F64F-CD4D-8092-A1FBD0226130}" type="datetimeFigureOut">
               <a:rPr lang="en-US" smtClean="0"/>
-              <a:t>4/16/26</a:t>
+              <a:t>5/14/26</a:t>
             </a:fld>
             <a:endParaRPr lang="en-US"/>
           </a:p>
@@ -1904,7 +1905,7 @@
           <a:p>
             <a:fld id="{376CE277-F64F-CD4D-8092-A1FBD0226130}" type="datetimeFigureOut">
               <a:rPr lang="en-US" smtClean="0"/>
-              <a:t>4/16/26</a:t>
+              <a:t>5/14/26</a:t>
             </a:fld>
             <a:endParaRPr lang="en-US"/>
           </a:p>
@@ -2079,7 +2080,7 @@
           <a:p>
             <a:fld id="{376CE277-F64F-CD4D-8092-A1FBD0226130}" type="datetimeFigureOut">
               <a:rPr lang="en-US" smtClean="0"/>
-              <a:t>4/16/26</a:t>
+              <a:t>5/14/26</a:t>
             </a:fld>
             <a:endParaRPr lang="en-US"/>
           </a:p>
@@ -2244,7 +2245,7 @@
           <a:p>
             <a:fld id="{376CE277-F64F-CD4D-8092-A1FBD0226130}" type="datetimeFigureOut">
               <a:rPr lang="en-US" smtClean="0"/>
-              <a:t>4/16/26</a:t>
+              <a:t>5/14/26</a:t>
             </a:fld>
             <a:endParaRPr lang="en-US"/>
           </a:p>
@@ -2485,7 +2486,7 @@
           <a:p>
             <a:fld id="{376CE277-F64F-CD4D-8092-A1FBD0226130}" type="datetimeFigureOut">
               <a:rPr lang="en-US" smtClean="0"/>
-              <a:t>4/16/26</a:t>
+              <a:t>5/14/26</a:t>
             </a:fld>
             <a:endParaRPr lang="en-US"/>
           </a:p>
@@ -2712,7 +2713,7 @@
           <a:p>
             <a:fld id="{376CE277-F64F-CD4D-8092-A1FBD0226130}" type="datetimeFigureOut">
               <a:rPr lang="en-US" smtClean="0"/>
-              <a:t>4/16/26</a:t>
+              <a:t>5/14/26</a:t>
             </a:fld>
             <a:endParaRPr lang="en-US"/>
           </a:p>
@@ -3074,7 +3075,7 @@
           <a:p>
             <a:fld id="{376CE277-F64F-CD4D-8092-A1FBD0226130}" type="datetimeFigureOut">
               <a:rPr lang="en-US" smtClean="0"/>
-              <a:t>4/16/26</a:t>
+              <a:t>5/14/26</a:t>
             </a:fld>
             <a:endParaRPr lang="en-US"/>
           </a:p>
@@ -3187,7 +3188,7 @@
           <a:p>
             <a:fld id="{376CE277-F64F-CD4D-8092-A1FBD0226130}" type="datetimeFigureOut">
               <a:rPr lang="en-US" smtClean="0"/>
-              <a:t>4/16/26</a:t>
+              <a:t>5/14/26</a:t>
             </a:fld>
             <a:endParaRPr lang="en-US"/>
           </a:p>
@@ -3277,7 +3278,7 @@
           <a:p>
             <a:fld id="{376CE277-F64F-CD4D-8092-A1FBD0226130}" type="datetimeFigureOut">
               <a:rPr lang="en-US" smtClean="0"/>
-              <a:t>4/16/26</a:t>
+              <a:t>5/14/26</a:t>
             </a:fld>
             <a:endParaRPr lang="en-US"/>
           </a:p>
@@ -3549,7 +3550,7 @@
           <a:p>
             <a:fld id="{376CE277-F64F-CD4D-8092-A1FBD0226130}" type="datetimeFigureOut">
               <a:rPr lang="en-US" smtClean="0"/>
-              <a:t>4/16/26</a:t>
+              <a:t>5/14/26</a:t>
             </a:fld>
             <a:endParaRPr lang="en-US"/>
           </a:p>
@@ -3797,7 +3798,7 @@
           <a:p>
             <a:fld id="{376CE277-F64F-CD4D-8092-A1FBD0226130}" type="datetimeFigureOut">
               <a:rPr lang="en-US" smtClean="0"/>
-              <a:t>4/16/26</a:t>
+              <a:t>5/14/26</a:t>
             </a:fld>
             <a:endParaRPr lang="en-US"/>
           </a:p>
@@ -4005,7 +4006,7 @@
           <a:p>
             <a:fld id="{376CE277-F64F-CD4D-8092-A1FBD0226130}" type="datetimeFigureOut">
               <a:rPr lang="en-US" smtClean="0"/>
-              <a:t>4/16/26</a:t>
+              <a:t>5/14/26</a:t>
             </a:fld>
             <a:endParaRPr lang="en-US"/>
           </a:p>
@@ -6422,6 +6423,201 @@
 </p:sld>
 </file>
 
+<file path=ppt/slides/slide6.xml><?xml version="1.0" encoding="utf-8"?>
+<p:sld xmlns:a="http://schemas.openxmlformats.org/drawingml/2006/main" xmlns:r="http://schemas.openxmlformats.org/officeDocument/2006/relationships" xmlns:p="http://schemas.openxmlformats.org/presentationml/2006/main">
+  <p:cSld>
+    <p:spTree>
+      <p:nvGrpSpPr>
+        <p:cNvPr id="1" name=""/>
+        <p:cNvGrpSpPr/>
+        <p:nvPr/>
+      </p:nvGrpSpPr>
+      <p:grpSpPr>
+        <a:xfrm>
+          <a:off x="0" y="0"/>
+          <a:ext cx="0" cy="0"/>
+          <a:chOff x="0" y="0"/>
+          <a:chExt cx="0" cy="0"/>
+        </a:xfrm>
+      </p:grpSpPr>
+      <p:sp>
+        <p:nvSpPr>
+          <p:cNvPr id="2" name="标题 1">
+            <a:extLst>
+              <a:ext uri="{FF2B5EF4-FFF2-40B4-BE49-F238E27FC236}">
+                <a16:creationId xmlns:a16="http://schemas.microsoft.com/office/drawing/2014/main" id="{83C79399-67B7-8D18-8662-0EBEC706B229}"/>
+              </a:ext>
+            </a:extLst>
+          </p:cNvPr>
+          <p:cNvSpPr>
+            <a:spLocks noGrp="1"/>
+          </p:cNvSpPr>
+          <p:nvPr>
+            <p:ph type="title"/>
+          </p:nvPr>
+        </p:nvSpPr>
+        <p:spPr/>
+        <p:txBody>
+          <a:bodyPr/>
+          <a:lstStyle/>
+          <a:p>
+            <a:endParaRPr kumimoji="1" lang="zh-CN" altLang="en-US"/>
+          </a:p>
+        </p:txBody>
+      </p:sp>
+      <p:sp>
+        <p:nvSpPr>
+          <p:cNvPr id="3" name="内容占位符 2">
+            <a:extLst>
+              <a:ext uri="{FF2B5EF4-FFF2-40B4-BE49-F238E27FC236}">
+                <a16:creationId xmlns:a16="http://schemas.microsoft.com/office/drawing/2014/main" id="{4BD50F6B-92DF-C6A7-9923-9E227BF85D4F}"/>
+              </a:ext>
+            </a:extLst>
+          </p:cNvPr>
+          <p:cNvSpPr>
+            <a:spLocks noGrp="1"/>
+          </p:cNvSpPr>
+          <p:nvPr>
+            <p:ph idx="1"/>
+          </p:nvPr>
+        </p:nvSpPr>
+        <p:spPr/>
+        <p:txBody>
+          <a:bodyPr/>
+          <a:lstStyle/>
+          <a:p>
+            <a:pPr marL="514350" indent="-514350">
+              <a:buFont typeface="+mj-lt"/>
+              <a:buAutoNum type="arabicPeriod"/>
+            </a:pPr>
+            <a:r>
+              <a:rPr kumimoji="1" lang="zh-CN" altLang="en-US"/>
+              <a:t>第一条标题</a:t>
+            </a:r>
+            <a:endParaRPr kumimoji="1" lang="en-US" altLang="zh-CN"/>
+          </a:p>
+          <a:p>
+            <a:pPr marL="971550" lvl="1" indent="-514350">
+              <a:buFont typeface="+mj-lt"/>
+              <a:buAutoNum type="arabicPeriod"/>
+            </a:pPr>
+            <a:r>
+              <a:rPr kumimoji="1" lang="zh-CN" altLang="en-US"/>
+              <a:t>内容</a:t>
+            </a:r>
+            <a:r>
+              <a:rPr kumimoji="1" lang="en-US" altLang="zh-CN"/>
+              <a:t>1</a:t>
+            </a:r>
+          </a:p>
+          <a:p>
+            <a:pPr marL="971550" lvl="1" indent="-514350">
+              <a:buFont typeface="+mj-lt"/>
+              <a:buAutoNum type="arabicPeriod"/>
+            </a:pPr>
+            <a:r>
+              <a:rPr kumimoji="1" lang="zh-CN" altLang="en-US"/>
+              <a:t>内容</a:t>
+            </a:r>
+            <a:r>
+              <a:rPr kumimoji="1" lang="en-US" altLang="zh-CN"/>
+              <a:t>2</a:t>
+            </a:r>
+          </a:p>
+          <a:p>
+            <a:pPr marL="514350" indent="-514350">
+              <a:buFont typeface="+mj-lt"/>
+              <a:buAutoNum type="arabicPeriod"/>
+            </a:pPr>
+            <a:r>
+              <a:rPr kumimoji="1" lang="zh-CN" altLang="en-US"/>
+              <a:t>第二条标题</a:t>
+            </a:r>
+            <a:endParaRPr kumimoji="1" lang="en-US" altLang="zh-CN"/>
+          </a:p>
+          <a:p>
+            <a:pPr marL="971550" lvl="1" indent="-514350">
+              <a:buFont typeface="+mj-lt"/>
+              <a:buAutoNum type="arabicPeriod"/>
+            </a:pPr>
+            <a:r>
+              <a:rPr kumimoji="1" lang="zh-CN" altLang="en-US"/>
+              <a:t>内容</a:t>
+            </a:r>
+            <a:r>
+              <a:rPr kumimoji="1" lang="en-US" altLang="zh-CN"/>
+              <a:t>3</a:t>
+            </a:r>
+          </a:p>
+          <a:p>
+            <a:pPr marL="971550" lvl="1" indent="-514350">
+              <a:buFont typeface="+mj-lt"/>
+              <a:buAutoNum type="arabicPeriod"/>
+            </a:pPr>
+            <a:r>
+              <a:rPr kumimoji="1" lang="zh-CN" altLang="en-US"/>
+              <a:t>内容</a:t>
+            </a:r>
+            <a:r>
+              <a:rPr kumimoji="1" lang="en-US" altLang="zh-CN"/>
+              <a:t>4</a:t>
+            </a:r>
+          </a:p>
+          <a:p>
+            <a:pPr marL="514350" indent="-514350">
+              <a:buFont typeface="+mj-lt"/>
+              <a:buAutoNum type="arabicPeriod"/>
+            </a:pPr>
+            <a:r>
+              <a:rPr kumimoji="1" lang="zh-CN" altLang="en-US"/>
+              <a:t>第三条标题</a:t>
+            </a:r>
+            <a:endParaRPr kumimoji="1" lang="en-US" altLang="zh-CN"/>
+          </a:p>
+          <a:p>
+            <a:pPr marL="971550" lvl="1" indent="-514350">
+              <a:buFont typeface="+mj-lt"/>
+              <a:buAutoNum type="arabicPeriod"/>
+            </a:pPr>
+            <a:r>
+              <a:rPr kumimoji="1" lang="zh-CN" altLang="en-US"/>
+              <a:t>内容</a:t>
+            </a:r>
+            <a:r>
+              <a:rPr kumimoji="1" lang="en-US" altLang="zh-CN"/>
+              <a:t>5</a:t>
+            </a:r>
+          </a:p>
+          <a:p>
+            <a:pPr marL="1428750" lvl="2" indent="-514350">
+              <a:buFont typeface="+mj-lt"/>
+              <a:buAutoNum type="arabicPeriod"/>
+            </a:pPr>
+            <a:r>
+              <a:rPr kumimoji="1" lang="zh-CN" altLang="en-US"/>
+              <a:t>内容</a:t>
+            </a:r>
+            <a:r>
+              <a:rPr kumimoji="1" lang="en-US" altLang="zh-CN"/>
+              <a:t>6</a:t>
+            </a:r>
+            <a:endParaRPr kumimoji="1" lang="zh-CN" altLang="en-US"/>
+          </a:p>
+        </p:txBody>
+      </p:sp>
+    </p:spTree>
+    <p:extLst>
+      <p:ext uri="{BB962C8B-B14F-4D97-AF65-F5344CB8AC3E}">
+        <p14:creationId xmlns:p14="http://schemas.microsoft.com/office/powerpoint/2010/main" val="1719225663"/>
+      </p:ext>
+    </p:extLst>
+  </p:cSld>
+  <p:clrMapOvr>
+    <a:masterClrMapping/>
+  </p:clrMapOvr>
+</p:sld>
+</file>
+
 <file path=ppt/theme/theme1.xml><?xml version="1.0" encoding="utf-8"?>
 <a:theme xmlns:a="http://schemas.openxmlformats.org/drawingml/2006/main" name="Office Theme">
   <a:themeElements>

</xml_diff>

<commit_message>
feat: add support for explicit list restarts in ordered lists handling
</commit_message>
<xml_diff>
--- a/demo/office_docs/pptx_01.pptx
+++ b/demo/office_docs/pptx_01.pptx
@@ -6461,7 +6461,10 @@
           <a:bodyPr/>
           <a:lstStyle/>
           <a:p>
-            <a:endParaRPr kumimoji="1" lang="zh-CN" altLang="en-US"/>
+            <a:r>
+              <a:rPr kumimoji="1" lang="zh-CN" altLang="en-US"/>
+              <a:t>多级列表和中断有序列表</a:t>
+            </a:r>
           </a:p>
         </p:txBody>
       </p:sp>
@@ -6481,9 +6484,16 @@
             <p:ph idx="1"/>
           </p:nvPr>
         </p:nvSpPr>
-        <p:spPr/>
-        <p:txBody>
-          <a:bodyPr/>
+        <p:spPr>
+          <a:xfrm>
+            <a:off x="838200" y="1825625"/>
+            <a:ext cx="3925186" cy="4351338"/>
+          </a:xfrm>
+        </p:spPr>
+        <p:txBody>
+          <a:bodyPr>
+            <a:normAutofit/>
+          </a:bodyPr>
           <a:lstStyle/>
           <a:p>
             <a:pPr marL="514350" indent="-514350">
@@ -6601,6 +6611,124 @@
               <a:rPr kumimoji="1" lang="en-US" altLang="zh-CN"/>
               <a:t>6</a:t>
             </a:r>
+            <a:endParaRPr kumimoji="1" lang="zh-CN" altLang="en-US"/>
+          </a:p>
+          <a:p>
+            <a:pPr>
+              <a:buNone/>
+            </a:pPr>
+            <a:endParaRPr lang="en-US" sz="1300"/>
+          </a:p>
+        </p:txBody>
+      </p:sp>
+      <p:sp>
+        <p:nvSpPr>
+          <p:cNvPr id="4" name="文本框 3">
+            <a:extLst>
+              <a:ext uri="{FF2B5EF4-FFF2-40B4-BE49-F238E27FC236}">
+                <a16:creationId xmlns:a16="http://schemas.microsoft.com/office/drawing/2014/main" id="{C202AD61-DE33-D4F2-735E-3F326D6BC502}"/>
+              </a:ext>
+            </a:extLst>
+          </p:cNvPr>
+          <p:cNvSpPr txBox="1"/>
+          <p:nvPr/>
+        </p:nvSpPr>
+        <p:spPr>
+          <a:xfrm>
+            <a:off x="5241852" y="2073348"/>
+            <a:ext cx="5493812" cy="1754326"/>
+          </a:xfrm>
+          <a:prstGeom prst="rect">
+            <a:avLst/>
+          </a:prstGeom>
+          <a:noFill/>
+        </p:spPr>
+        <p:txBody>
+          <a:bodyPr wrap="none" rtlCol="0">
+            <a:spAutoFit/>
+          </a:bodyPr>
+          <a:lstStyle/>
+          <a:p>
+            <a:pPr>
+              <a:buNone/>
+            </a:pPr>
+            <a:r>
+              <a:rPr lang="en" altLang="zh-CN"/>
+              <a:t>【PPTX</a:t>
+            </a:r>
+            <a:r>
+              <a:rPr lang="zh-CN" altLang="en-US"/>
+              <a:t>中断有序列表测试</a:t>
+            </a:r>
+            <a:r>
+              <a:rPr lang="en-US" altLang="zh-CN"/>
+              <a:t>】</a:t>
+            </a:r>
+          </a:p>
+          <a:p>
+            <a:pPr marL="514350" indent="-342900">
+              <a:buFont typeface="+mj-lt"/>
+              <a:buAutoNum type="arabicPeriod"/>
+            </a:pPr>
+            <a:r>
+              <a:rPr lang="zh-CN" altLang="en-US"/>
+              <a:t>中断列表第</a:t>
+            </a:r>
+            <a:r>
+              <a:rPr lang="en-US" altLang="zh-CN"/>
+              <a:t>1</a:t>
+            </a:r>
+            <a:r>
+              <a:rPr lang="zh-CN" altLang="en-US"/>
+              <a:t>项</a:t>
+            </a:r>
+          </a:p>
+          <a:p>
+            <a:pPr marL="514350" indent="-342900">
+              <a:buFont typeface="+mj-lt"/>
+              <a:buAutoNum type="arabicPeriod"/>
+            </a:pPr>
+            <a:r>
+              <a:rPr lang="zh-CN" altLang="en-US"/>
+              <a:t>中断列表第</a:t>
+            </a:r>
+            <a:r>
+              <a:rPr lang="en-US" altLang="zh-CN"/>
+              <a:t>2</a:t>
+            </a:r>
+            <a:r>
+              <a:rPr lang="zh-CN" altLang="en-US"/>
+              <a:t>项</a:t>
+            </a:r>
+          </a:p>
+          <a:p>
+            <a:pPr>
+              <a:buNone/>
+            </a:pPr>
+            <a:r>
+              <a:rPr lang="zh-CN" altLang="en-US"/>
+              <a:t>这里是插入在列表中间的普通正文，不应作为列表项</a:t>
+            </a:r>
+          </a:p>
+          <a:p>
+            <a:pPr marL="514350" indent="-342900">
+              <a:buFont typeface="+mj-lt"/>
+              <a:buAutoNum type="arabicPeriod" startAt="3"/>
+            </a:pPr>
+            <a:r>
+              <a:rPr lang="zh-CN" altLang="en-US"/>
+              <a:t>中断列表第</a:t>
+            </a:r>
+            <a:r>
+              <a:rPr lang="en-US" altLang="zh-CN"/>
+              <a:t>3</a:t>
+            </a:r>
+            <a:r>
+              <a:rPr lang="zh-CN" altLang="en-US"/>
+              <a:t>项（正文后继续编号）</a:t>
+            </a:r>
+          </a:p>
+          <a:p>
             <a:endParaRPr kumimoji="1" lang="zh-CN" altLang="en-US"/>
           </a:p>
         </p:txBody>

</xml_diff>